<commit_message>
deck: remove empty paragraphs left by merge (CN now matches EN line-for-line); refresh update pack
</commit_message>
<xml_diff>
--- a/submit/TeaWindow_路演_设计版.pptx
+++ b/submit/TeaWindow_路演_设计版.pptx
@@ -20838,44 +20838,6 @@
             <a:endParaRPr lang="en-US" sz="1100"/>
           </a:p>
           <a:p>
-            <a:pPr marL="0" indent="0" algn="l">
-              <a:lnSpc>
-                <a:spcPct val="150000"/>
-              </a:lnSpc>
-            </a:pPr>
-            <a:r>
-              <a:rPr lang="en-US" sz="1600" b="0" i="0" u="none" strike="noStrike">
-                <a:solidFill>
-                  <a:srgbClr val="CED9E4"/>
-                </a:solidFill>
-                <a:latin typeface="Inter"/>
-                <a:ea typeface="Inter"/>
-                <a:cs typeface="Inter"/>
-                <a:sym typeface="Inter"/>
-              </a:rPr>
-              <a:t/>
-            </a:r>
-          </a:p>
-          <a:p>
-            <a:pPr marL="0" indent="0" algn="l">
-              <a:lnSpc>
-                <a:spcPct val="150000"/>
-              </a:lnSpc>
-            </a:pPr>
-            <a:r>
-              <a:rPr lang="en-US" sz="1600" b="0" i="0" u="none" strike="noStrike">
-                <a:solidFill>
-                  <a:srgbClr val="CED9E4"/>
-                </a:solidFill>
-                <a:latin typeface="Inter"/>
-                <a:ea typeface="Inter"/>
-                <a:cs typeface="Inter"/>
-                <a:sym typeface="Inter"/>
-              </a:rPr>
-              <a:t/>
-            </a:r>
-          </a:p>
-          <a:p>
             <a:r>
               <a:t>• 把「倒春寒 × 高温 × 干旱」变成可执行的地块级判断</a:t>
             </a:r>
@@ -21089,63 +21051,6 @@
               <a:t>• 春霜 357 天：Tmin MAE 1.32℃(CI 1.21–1.43) vs 持续法 2.08℃</a:t>
             </a:r>
             <a:endParaRPr lang="en-US" sz="1100"/>
-          </a:p>
-          <a:p>
-            <a:pPr marL="0" indent="0" algn="l">
-              <a:lnSpc>
-                <a:spcPct val="150000"/>
-              </a:lnSpc>
-            </a:pPr>
-            <a:r>
-              <a:rPr lang="en-US" sz="1600" b="0" i="0" u="none" strike="noStrike">
-                <a:solidFill>
-                  <a:srgbClr val="CED9E4"/>
-                </a:solidFill>
-                <a:latin typeface="Inter"/>
-                <a:ea typeface="Inter"/>
-                <a:cs typeface="Inter"/>
-                <a:sym typeface="Inter"/>
-              </a:rPr>
-              <a:t/>
-            </a:r>
-          </a:p>
-          <a:p>
-            <a:pPr marL="0" indent="0" algn="l">
-              <a:lnSpc>
-                <a:spcPct val="150000"/>
-              </a:lnSpc>
-            </a:pPr>
-            <a:r>
-              <a:rPr lang="en-US" sz="1600" b="0" i="0" u="none" strike="noStrike">
-                <a:solidFill>
-                  <a:srgbClr val="CED9E4"/>
-                </a:solidFill>
-                <a:latin typeface="Inter"/>
-                <a:ea typeface="Inter"/>
-                <a:cs typeface="Inter"/>
-                <a:sym typeface="Inter"/>
-              </a:rPr>
-              <a:t/>
-            </a:r>
-          </a:p>
-          <a:p>
-            <a:pPr marL="0" indent="0" algn="l">
-              <a:lnSpc>
-                <a:spcPct val="150000"/>
-              </a:lnSpc>
-            </a:pPr>
-            <a:r>
-              <a:rPr lang="en-US" sz="1600" b="0" i="0" u="none" strike="noStrike">
-                <a:solidFill>
-                  <a:srgbClr val="CED9E4"/>
-                </a:solidFill>
-                <a:latin typeface="Inter"/>
-                <a:ea typeface="Inter"/>
-                <a:cs typeface="Inter"/>
-                <a:sym typeface="Inter"/>
-              </a:rPr>
-              <a:t/>
-            </a:r>
           </a:p>
           <a:p>
             <a:r>
@@ -21843,56 +21748,6 @@
             </a:r>
             <a:endParaRPr lang="en-US" sz="1100"/>
           </a:p>
-          <a:p>
-            <a:pPr marL="0" indent="0" algn="ctr">
-              <a:lnSpc>
-                <a:spcPct val="125000"/>
-              </a:lnSpc>
-            </a:pPr>
-            <a:r>
-              <a:rPr lang="en-US" sz="3200" b="1" i="0" u="none" strike="noStrike">
-                <a:solidFill>
-                  <a:srgbClr val="4AA8FF"/>
-                </a:solidFill>
-                <a:latin typeface="Montserrat"/>
-                <a:ea typeface="Montserrat"/>
-                <a:cs typeface="Montserrat"/>
-                <a:sym typeface="Montserrat"/>
-              </a:rPr>
-              <a:t/>
-            </a:r>
-            <a:r>
-              <a:rPr lang="en-US" sz="3200" b="1" i="0" u="none" strike="noStrike">
-                <a:solidFill>
-                  <a:srgbClr val="E8EEF3"/>
-                </a:solidFill>
-                <a:latin typeface="Montserrat"/>
-                <a:ea typeface="Montserrat"/>
-                <a:cs typeface="Montserrat"/>
-                <a:sym typeface="Montserrat"/>
-              </a:rPr>
-              <a:t/>
-            </a:r>
-          </a:p>
-          <a:p>
-            <a:pPr marL="0" indent="0" algn="ctr">
-              <a:lnSpc>
-                <a:spcPct val="125000"/>
-              </a:lnSpc>
-            </a:pPr>
-            <a:r>
-              <a:rPr lang="en-US" sz="3200" b="1" i="0" u="none" strike="noStrike">
-                <a:solidFill>
-                  <a:srgbClr val="4AA8FF"/>
-                </a:solidFill>
-                <a:latin typeface="Montserrat"/>
-                <a:ea typeface="Montserrat"/>
-                <a:cs typeface="Montserrat"/>
-                <a:sym typeface="Montserrat"/>
-              </a:rPr>
-              <a:t/>
-            </a:r>
-          </a:p>
         </p:txBody>
       </p:sp>
       <p:sp>
@@ -21986,44 +21841,6 @@
               <a:t>• 在线 https://teawindow.onrender.com/</a:t>
             </a:r>
             <a:endParaRPr lang="en-US" sz="1100"/>
-          </a:p>
-          <a:p>
-            <a:pPr marL="0" indent="0" algn="ctr">
-              <a:lnSpc>
-                <a:spcPct val="158333"/>
-              </a:lnSpc>
-            </a:pPr>
-            <a:r>
-              <a:rPr lang="en-US" sz="1600" b="0" i="0" u="none" strike="noStrike">
-                <a:solidFill>
-                  <a:srgbClr val="9FB4C6"/>
-                </a:solidFill>
-                <a:latin typeface="Inter"/>
-                <a:ea typeface="Inter"/>
-                <a:cs typeface="Inter"/>
-                <a:sym typeface="Inter"/>
-              </a:rPr>
-              <a:t/>
-            </a:r>
-          </a:p>
-          <a:p>
-            <a:pPr marL="0" indent="0" algn="ctr">
-              <a:lnSpc>
-                <a:spcPct val="158333"/>
-              </a:lnSpc>
-            </a:pPr>
-            <a:r>
-              <a:rPr lang="en-US" sz="1600" b="0" i="0" u="none" strike="noStrike">
-                <a:solidFill>
-                  <a:srgbClr val="9FB4C6"/>
-                </a:solidFill>
-                <a:latin typeface="Inter"/>
-                <a:ea typeface="Inter"/>
-                <a:cs typeface="Inter"/>
-                <a:sym typeface="Inter"/>
-              </a:rPr>
-              <a:t/>
-            </a:r>
           </a:p>
           <a:p>
             <a:r>
@@ -22265,44 +22082,6 @@
             <a:endParaRPr lang="en-US" sz="1100"/>
           </a:p>
           <a:p>
-            <a:pPr marL="0" indent="0" algn="l">
-              <a:lnSpc>
-                <a:spcPct val="150000"/>
-              </a:lnSpc>
-            </a:pPr>
-            <a:r>
-              <a:rPr lang="en-US" sz="1600" b="0" i="0" u="none" strike="noStrike">
-                <a:solidFill>
-                  <a:srgbClr val="CED9E4"/>
-                </a:solidFill>
-                <a:latin typeface="Inter"/>
-                <a:ea typeface="Inter"/>
-                <a:cs typeface="Inter"/>
-                <a:sym typeface="Inter"/>
-              </a:rPr>
-              <a:t/>
-            </a:r>
-          </a:p>
-          <a:p>
-            <a:pPr marL="0" indent="0" algn="l">
-              <a:lnSpc>
-                <a:spcPct val="150000"/>
-              </a:lnSpc>
-            </a:pPr>
-            <a:r>
-              <a:rPr lang="en-US" sz="1600" b="0" i="0" u="none" strike="noStrike">
-                <a:solidFill>
-                  <a:srgbClr val="CED9E4"/>
-                </a:solidFill>
-                <a:latin typeface="Inter"/>
-                <a:ea typeface="Inter"/>
-                <a:cs typeface="Inter"/>
-                <a:sym typeface="Inter"/>
-              </a:rPr>
-              <a:t/>
-            </a:r>
-          </a:p>
-          <a:p>
             <a:r>
               <a:t>• 2010 浙江冻害：约 150 万亩、损失约 17 亿元（西湖区近 3 成受冻、推迟约 10 天）</a:t>
             </a:r>
@@ -23067,63 +22846,6 @@
             <a:endParaRPr lang="en-US" sz="1100"/>
           </a:p>
           <a:p>
-            <a:pPr marL="0" indent="0" algn="l">
-              <a:lnSpc>
-                <a:spcPct val="150000"/>
-              </a:lnSpc>
-            </a:pPr>
-            <a:r>
-              <a:rPr lang="en-US" sz="1600" b="0" i="0" u="none" strike="noStrike">
-                <a:solidFill>
-                  <a:srgbClr val="CED9E4"/>
-                </a:solidFill>
-                <a:latin typeface="Inter"/>
-                <a:ea typeface="Inter"/>
-                <a:cs typeface="Inter"/>
-                <a:sym typeface="Inter"/>
-              </a:rPr>
-              <a:t/>
-            </a:r>
-          </a:p>
-          <a:p>
-            <a:pPr marL="0" indent="0" algn="l">
-              <a:lnSpc>
-                <a:spcPct val="150000"/>
-              </a:lnSpc>
-            </a:pPr>
-            <a:r>
-              <a:rPr lang="en-US" sz="1600" b="0" i="0" u="none" strike="noStrike">
-                <a:solidFill>
-                  <a:srgbClr val="CED9E4"/>
-                </a:solidFill>
-                <a:latin typeface="Inter"/>
-                <a:ea typeface="Inter"/>
-                <a:cs typeface="Inter"/>
-                <a:sym typeface="Inter"/>
-              </a:rPr>
-              <a:t/>
-            </a:r>
-          </a:p>
-          <a:p>
-            <a:pPr marL="0" indent="0" algn="l">
-              <a:lnSpc>
-                <a:spcPct val="150000"/>
-              </a:lnSpc>
-            </a:pPr>
-            <a:r>
-              <a:rPr lang="en-US" sz="1600" b="0" i="0" u="none" strike="noStrike">
-                <a:solidFill>
-                  <a:srgbClr val="CED9E4"/>
-                </a:solidFill>
-                <a:latin typeface="Inter"/>
-                <a:ea typeface="Inter"/>
-                <a:cs typeface="Inter"/>
-                <a:sym typeface="Inter"/>
-              </a:rPr>
-              <a:t/>
-            </a:r>
-          </a:p>
-          <a:p>
             <a:r>
               <a:t>• 指标引擎：积温/霜冻/倒春寒/高温/干旱/连阴雨</a:t>
             </a:r>
@@ -23421,63 +23143,6 @@
             <a:endParaRPr lang="en-US" sz="1100"/>
           </a:p>
           <a:p>
-            <a:pPr marL="0" indent="0" algn="l">
-              <a:lnSpc>
-                <a:spcPct val="150000"/>
-              </a:lnSpc>
-            </a:pPr>
-            <a:r>
-              <a:rPr lang="en-US" sz="1600" b="0" i="0" u="none" strike="noStrike">
-                <a:solidFill>
-                  <a:srgbClr val="CED9E4"/>
-                </a:solidFill>
-                <a:latin typeface="Inter"/>
-                <a:ea typeface="Inter"/>
-                <a:cs typeface="Inter"/>
-                <a:sym typeface="Inter"/>
-              </a:rPr>
-              <a:t/>
-            </a:r>
-          </a:p>
-          <a:p>
-            <a:pPr marL="0" indent="0" algn="l">
-              <a:lnSpc>
-                <a:spcPct val="150000"/>
-              </a:lnSpc>
-            </a:pPr>
-            <a:r>
-              <a:rPr lang="en-US" sz="1600" b="0" i="0" u="none" strike="noStrike">
-                <a:solidFill>
-                  <a:srgbClr val="CED9E4"/>
-                </a:solidFill>
-                <a:latin typeface="Inter"/>
-                <a:ea typeface="Inter"/>
-                <a:cs typeface="Inter"/>
-                <a:sym typeface="Inter"/>
-              </a:rPr>
-              <a:t/>
-            </a:r>
-          </a:p>
-          <a:p>
-            <a:pPr marL="0" indent="0" algn="l">
-              <a:lnSpc>
-                <a:spcPct val="150000"/>
-              </a:lnSpc>
-            </a:pPr>
-            <a:r>
-              <a:rPr lang="en-US" sz="1600" b="0" i="0" u="none" strike="noStrike">
-                <a:solidFill>
-                  <a:srgbClr val="CED9E4"/>
-                </a:solidFill>
-                <a:latin typeface="Inter"/>
-                <a:ea typeface="Inter"/>
-                <a:cs typeface="Inter"/>
-                <a:sym typeface="Inter"/>
-              </a:rPr>
-              <a:t/>
-            </a:r>
-          </a:p>
-          <a:p>
             <a:r>
               <a:t>• 留出年 2024–2025：AUC 0.998 / F1 0.85 vs 单阈值 0.78 / 0.50（弱标签复现）</a:t>
             </a:r>
@@ -23733,44 +23398,6 @@
             <a:endParaRPr lang="en-US" sz="1100"/>
           </a:p>
           <a:p>
-            <a:pPr marL="0" indent="0" algn="l">
-              <a:lnSpc>
-                <a:spcPct val="158333"/>
-              </a:lnSpc>
-            </a:pPr>
-            <a:r>
-              <a:rPr lang="en-US" sz="1600" b="0" i="0" u="none" strike="noStrike">
-                <a:solidFill>
-                  <a:srgbClr val="CED9E4"/>
-                </a:solidFill>
-                <a:latin typeface="Inter"/>
-                <a:ea typeface="Inter"/>
-                <a:cs typeface="Inter"/>
-                <a:sym typeface="Inter"/>
-              </a:rPr>
-              <a:t/>
-            </a:r>
-          </a:p>
-          <a:p>
-            <a:pPr marL="0" indent="0" algn="l">
-              <a:lnSpc>
-                <a:spcPct val="158333"/>
-              </a:lnSpc>
-            </a:pPr>
-            <a:r>
-              <a:rPr lang="en-US" sz="1600" b="0" i="0" u="none" strike="noStrike">
-                <a:solidFill>
-                  <a:srgbClr val="CED9E4"/>
-                </a:solidFill>
-                <a:latin typeface="Inter"/>
-                <a:ea typeface="Inter"/>
-                <a:cs typeface="Inter"/>
-                <a:sym typeface="Inter"/>
-              </a:rPr>
-              <a:t/>
-            </a:r>
-          </a:p>
-          <a:p>
             <a:r>
               <a:t>• 价值闭环：预期损失 / 保费；天气指数保险（地块级定价）</a:t>
             </a:r>
@@ -24021,63 +23648,6 @@
             <a:endParaRPr lang="en-US" sz="1100"/>
           </a:p>
           <a:p>
-            <a:pPr marL="0" indent="0" algn="l">
-              <a:lnSpc>
-                <a:spcPct val="150000"/>
-              </a:lnSpc>
-            </a:pPr>
-            <a:r>
-              <a:rPr lang="en-US" sz="1600" b="0" i="0" u="none" strike="noStrike">
-                <a:solidFill>
-                  <a:srgbClr val="CED9E4"/>
-                </a:solidFill>
-                <a:latin typeface="Inter"/>
-                <a:ea typeface="Inter"/>
-                <a:cs typeface="Inter"/>
-                <a:sym typeface="Inter"/>
-              </a:rPr>
-              <a:t/>
-            </a:r>
-          </a:p>
-          <a:p>
-            <a:pPr marL="0" indent="0" algn="l">
-              <a:lnSpc>
-                <a:spcPct val="150000"/>
-              </a:lnSpc>
-            </a:pPr>
-            <a:r>
-              <a:rPr lang="en-US" sz="1600" b="0" i="0" u="none" strike="noStrike">
-                <a:solidFill>
-                  <a:srgbClr val="CED9E4"/>
-                </a:solidFill>
-                <a:latin typeface="Inter"/>
-                <a:ea typeface="Inter"/>
-                <a:cs typeface="Inter"/>
-                <a:sym typeface="Inter"/>
-              </a:rPr>
-              <a:t/>
-            </a:r>
-          </a:p>
-          <a:p>
-            <a:pPr marL="0" indent="0" algn="l">
-              <a:lnSpc>
-                <a:spcPct val="150000"/>
-              </a:lnSpc>
-            </a:pPr>
-            <a:r>
-              <a:rPr lang="en-US" sz="1600" b="0" i="0" u="none" strike="noStrike">
-                <a:solidFill>
-                  <a:srgbClr val="CED9E4"/>
-                </a:solidFill>
-                <a:latin typeface="Inter"/>
-                <a:ea typeface="Inter"/>
-                <a:cs typeface="Inter"/>
-                <a:sym typeface="Inter"/>
-              </a:rPr>
-              <a:t/>
-            </a:r>
-          </a:p>
-          <a:p>
             <a:r>
               <a:t>• 自研问答：ONNX 意图 + 事实接地 + 来源链</a:t>
             </a:r>
@@ -25019,25 +24589,6 @@
             </a:r>
             <a:endParaRPr lang="en-US" sz="1100"/>
           </a:p>
-          <a:p>
-            <a:pPr marL="0" indent="0" algn="l">
-              <a:lnSpc>
-                <a:spcPct val="141666"/>
-              </a:lnSpc>
-            </a:pPr>
-            <a:r>
-              <a:rPr lang="en-US" sz="1600" b="0" i="0" u="none" strike="noStrike">
-                <a:solidFill>
-                  <a:srgbClr val="CED9E4"/>
-                </a:solidFill>
-                <a:latin typeface="Inter"/>
-                <a:ea typeface="Inter"/>
-                <a:cs typeface="Inter"/>
-                <a:sym typeface="Inter"/>
-              </a:rPr>
-              <a:t/>
-            </a:r>
-          </a:p>
         </p:txBody>
       </p:sp>
       <p:sp>
@@ -25127,25 +24678,6 @@
             </a:r>
             <a:endParaRPr lang="en-US" sz="1100"/>
           </a:p>
-          <a:p>
-            <a:pPr marL="0" indent="0" algn="l">
-              <a:lnSpc>
-                <a:spcPct val="141666"/>
-              </a:lnSpc>
-            </a:pPr>
-            <a:r>
-              <a:rPr lang="en-US" sz="1600" b="0" i="0" u="none" strike="noStrike">
-                <a:solidFill>
-                  <a:srgbClr val="CED9E4"/>
-                </a:solidFill>
-                <a:latin typeface="Inter"/>
-                <a:ea typeface="Inter"/>
-                <a:cs typeface="Inter"/>
-                <a:sym typeface="Inter"/>
-              </a:rPr>
-              <a:t/>
-            </a:r>
-          </a:p>
         </p:txBody>
       </p:sp>
       <p:sp>
@@ -25234,25 +24766,6 @@
               <a:t>• 第 3 步 追问或出卡：点「用问答追问」问「这块地未来 3 天怎么管」，或点「地块体检卡」打印</a:t>
             </a:r>
             <a:endParaRPr lang="en-US" sz="1100"/>
-          </a:p>
-          <a:p>
-            <a:pPr marL="0" indent="0" algn="l">
-              <a:lnSpc>
-                <a:spcPct val="141666"/>
-              </a:lnSpc>
-            </a:pPr>
-            <a:r>
-              <a:rPr lang="en-US" sz="1600" b="0" i="0" u="none" strike="noStrike">
-                <a:solidFill>
-                  <a:srgbClr val="CED9E4"/>
-                </a:solidFill>
-                <a:latin typeface="Inter"/>
-                <a:ea typeface="Inter"/>
-                <a:cs typeface="Inter"/>
-                <a:sym typeface="Inter"/>
-              </a:rPr>
-              <a:t/>
-            </a:r>
           </a:p>
         </p:txBody>
       </p:sp>

</xml_diff>

<commit_message>
deck: force explicit light color/size on inherited runs (CN slide 2 readable)
</commit_message>
<xml_diff>
--- a/submit/TeaWindow_路演_设计版.pptx
+++ b/submit/TeaWindow_路演_设计版.pptx
@@ -20839,11 +20839,23 @@
           </a:p>
           <a:p>
             <a:r>
+              <a:rPr sz="1600">
+                <a:solidFill>
+                  <a:srgbClr val="CED9E4"/>
+                </a:solidFill>
+                <a:latin typeface="Inter"/>
+              </a:rPr>
               <a:t>• 把「倒春寒 × 高温 × 干旱」变成可执行的地块级判断</a:t>
             </a:r>
           </a:p>
           <a:p>
             <a:r>
+              <a:rPr sz="1600">
+                <a:solidFill>
+                  <a:srgbClr val="CED9E4"/>
+                </a:solidFill>
+                <a:latin typeface="Inter"/>
+              </a:rPr>
               <a:t>• One Place · One Climate Problem · One AI Solution</a:t>
             </a:r>
           </a:p>
@@ -21054,16 +21066,34 @@
           </a:p>
           <a:p>
             <a:r>
+              <a:rPr sz="1600">
+                <a:solidFill>
+                  <a:srgbClr val="CED9E4"/>
+                </a:solidFill>
+                <a:latin typeface="Inter"/>
+              </a:rPr>
               <a:t>• 1/3/7 天 MAE 0.49/0.67/0.91℃；POD 0.709 / FAR 0 / CSI 0.709</a:t>
             </a:r>
           </a:p>
           <a:p>
             <a:r>
+              <a:rPr sz="1600">
+                <a:solidFill>
+                  <a:srgbClr val="CED9E4"/>
+                </a:solidFill>
+                <a:latin typeface="Inter"/>
+              </a:rPr>
               <a:t>• 事件回测 7/7；下一步：冻结版本 + 地块级传感器 + 正/负田间记录</a:t>
             </a:r>
           </a:p>
           <a:p>
             <a:r>
+              <a:rPr sz="1600">
+                <a:solidFill>
+                  <a:srgbClr val="CED9E4"/>
+                </a:solidFill>
+                <a:latin typeface="Inter"/>
+              </a:rPr>
               <a:t>• 90 天真实场景验证计划；决策辅助，不替代官方预警</a:t>
             </a:r>
           </a:p>
@@ -21844,11 +21874,23 @@
           </a:p>
           <a:p>
             <a:r>
+              <a:rPr sz="1600">
+                <a:solidFill>
+                  <a:srgbClr val="9FB4C6"/>
+                </a:solidFill>
+                <a:latin typeface="Inter"/>
+              </a:rPr>
               <a:t>• 静态 https://eric2007-sudo.github.io/TeaWindow/</a:t>
             </a:r>
           </a:p>
           <a:p>
             <a:r>
+              <a:rPr sz="1600">
+                <a:solidFill>
+                  <a:srgbClr val="9FB4C6"/>
+                </a:solidFill>
+                <a:latin typeface="Inter"/>
+              </a:rPr>
               <a:t>• 仓库 https://github.com/Eric2007-sudo/TeaWindow</a:t>
             </a:r>
           </a:p>
@@ -22083,11 +22125,23 @@
           </a:p>
           <a:p>
             <a:r>
+              <a:rPr sz="1600">
+                <a:solidFill>
+                  <a:srgbClr val="CED9E4"/>
+                </a:solidFill>
+                <a:latin typeface="Inter"/>
+              </a:rPr>
               <a:t>• 2010 浙江冻害：约 150 万亩、损失约 17 亿元（西湖区近 3 成受冻、推迟约 10 天）</a:t>
             </a:r>
           </a:p>
           <a:p>
             <a:r>
+              <a:rPr sz="1600">
+                <a:solidFill>
+                  <a:srgbClr val="CED9E4"/>
+                </a:solidFill>
+                <a:latin typeface="Inter"/>
+              </a:rPr>
               <a:t>• 2020/2022 西湖区约 5000 亩高温灼伤；2024 杭州高温 60 天（破纪录）</a:t>
             </a:r>
           </a:p>
@@ -22847,16 +22901,34 @@
           </a:p>
           <a:p>
             <a:r>
+              <a:rPr sz="1600">
+                <a:solidFill>
+                  <a:srgbClr val="CED9E4"/>
+                </a:solidFill>
+                <a:latin typeface="Inter"/>
+              </a:rPr>
               <a:t>• 指标引擎：积温/霜冻/倒春寒/高温/干旱/连阴雨</a:t>
             </a:r>
           </a:p>
           <a:p>
             <a:r>
+              <a:rPr sz="1600">
+                <a:solidFill>
+                  <a:srgbClr val="CED9E4"/>
+                </a:solidFill>
+                <a:latin typeface="Inter"/>
+              </a:rPr>
               <a:t>• 模型：numpy GBDT 复合风险 → 透明规则采摘适宜度与最佳窗口</a:t>
             </a:r>
           </a:p>
           <a:p>
             <a:r>
+              <a:rPr sz="1600">
+                <a:solidFill>
+                  <a:srgbClr val="CED9E4"/>
+                </a:solidFill>
+                <a:latin typeface="Inter"/>
+              </a:rPr>
               <a:t>• 输出：茶农白话行动建议（离线/在线双形态）</a:t>
             </a:r>
           </a:p>
@@ -23144,16 +23216,34 @@
           </a:p>
           <a:p>
             <a:r>
+              <a:rPr sz="1600">
+                <a:solidFill>
+                  <a:srgbClr val="CED9E4"/>
+                </a:solidFill>
+                <a:latin typeface="Inter"/>
+              </a:rPr>
               <a:t>• 留出年 2024–2025：AUC 0.998 / F1 0.85 vs 单阈值 0.78 / 0.50（弱标签复现）</a:t>
             </a:r>
           </a:p>
           <a:p>
             <a:r>
+              <a:rPr sz="1600">
+                <a:solidFill>
+                  <a:srgbClr val="CED9E4"/>
+                </a:solidFill>
+                <a:latin typeface="Inter"/>
+              </a:rPr>
               <a:t>• 集合预报给不确定性区间；地形 + NDVI 做地块级解释</a:t>
             </a:r>
           </a:p>
           <a:p>
             <a:r>
+              <a:rPr sz="1600">
+                <a:solidFill>
+                  <a:srgbClr val="CED9E4"/>
+                </a:solidFill>
+                <a:latin typeface="Inter"/>
+              </a:rPr>
               <a:t>• 明确：弱标签 ≠ 田间精度</a:t>
             </a:r>
           </a:p>
@@ -23399,11 +23489,23 @@
           </a:p>
           <a:p>
             <a:r>
+              <a:rPr sz="1600">
+                <a:solidFill>
+                  <a:srgbClr val="CED9E4"/>
+                </a:solidFill>
+                <a:latin typeface="Inter"/>
+              </a:rPr>
               <a:t>• 价值闭环：预期损失 / 保费；天气指数保险（地块级定价）</a:t>
             </a:r>
           </a:p>
           <a:p>
             <a:r>
+              <a:rPr sz="1600">
+                <a:solidFill>
+                  <a:srgbClr val="CED9E4"/>
+                </a:solidFill>
+                <a:latin typeface="Inter"/>
+              </a:rPr>
               <a:t>• 地块级霜冻易感（地形/坡向）</a:t>
             </a:r>
           </a:p>
@@ -23649,16 +23751,34 @@
           </a:p>
           <a:p>
             <a:r>
+              <a:rPr sz="1600">
+                <a:solidFill>
+                  <a:srgbClr val="CED9E4"/>
+                </a:solidFill>
+                <a:latin typeface="Inter"/>
+              </a:rPr>
               <a:t>• 自研问答：ONNX 意图 + 事实接地 + 来源链</a:t>
             </a:r>
           </a:p>
           <a:p>
             <a:r>
+              <a:rPr sz="1600">
+                <a:solidFill>
+                  <a:srgbClr val="CED9E4"/>
+                </a:solidFill>
+                <a:latin typeface="Inter"/>
+              </a:rPr>
               <a:t>• 多维复合提问分项作答 · JSON/表格跨轮一致 · 任务引用与记忆</a:t>
             </a:r>
           </a:p>
           <a:p>
             <a:r>
+              <a:rPr sz="1600">
+                <a:solidFill>
+                  <a:srgbClr val="CED9E4"/>
+                </a:solidFill>
+                <a:latin typeface="Inter"/>
+              </a:rPr>
               <a:t>• 运行闭环：3h 刷新 + 漂移检测 + 过期降级 + 告警（钉钉加签真实送达）</a:t>
             </a:r>
           </a:p>

</xml_diff>